<commit_message>
F4: alinea notebook, informe y presentación (carga desde GitHub, trazabilidad de cifras, bibliografía y precisiones de redacción)
</commit_message>
<xml_diff>
--- a/MCDI503/docs/mcdi503_f4_presentacion_grupo5.pptx
+++ b/MCDI503/docs/mcdi503_f4_presentacion_grupo5.pptx
@@ -1908,7 +1908,7 @@
           <a:p/>
           <a:p>
             <a:r>
-              <a:t>Con ellos resolvimos tres redundancias. Primera: las seis columnas heredadas de seaborn-data se reconstruyen al cien por ciento a partir de columnas propias, así que se descartan. Segunda: Title_agrupado y Sex tienen una V de Cramér de 0,995 entre sí; nos quedamos con Title_agrupado, porque distingue a los niños, y descartamos Sex_bin. Tercera, la redundancia exacta: IsAlone es una función de FamilySize, y Pclass es una combinación lineal exacta de las dummies de Sex_Pclass, que ya contiene sexo y clase. Una variable que es función exacta de otras no aporta información nueva y además genera colinealidad perfecta, así que descartamos ambas.</a:t>
+              <a:t>Con ellos resolvimos tres redundancias. Primera: las seis columnas heredadas de seaborn-data coinciden con columnas propias: who, adult_male y alone se reconstruyen al cien por ciento en este notebook, y las otras tres ya se habían validado en las Fases 2 y 3; por eso se descartan. Segunda: Title_agrupado y Sex tienen una V de Cramér de 0,995 entre sí; nos quedamos con Title_agrupado, porque distingue a los niños, y descartamos Sex_bin. Tercera, la redundancia exacta: IsAlone es una función de FamilySize, y Pclass es una combinación lineal exacta de las dummies de Sex_Pclass, que ya contiene sexo y clase. Una variable que es función exacta de otras no aporta información nueva y además genera colinealidad perfecta, así que descartamos ambas.</a:t>
             </a:r>
           </a:p>
           <a:p/>
@@ -2342,7 +2342,7 @@
           <a:p/>
           <a:p>
             <a:r>
-              <a:t>"La trazabilidad es un requisito central. El notebook está ejecutado de principio a fin, con rutas relativas, semilla fija en 42 y dependencias en requirements.txt. Cada acción del pipeline queda en una bitácora de diez pasos con su efecto en los datos, y las decisiones de selección, en una tabla única, y el destino de cada una de las 36 columnas, en un inventario.</a:t>
+              <a:t>"La trazabilidad es un requisito central. El notebook está ejecutado de principio a fin, lee los datos directamente desde sus fuentes públicas en GitHub, verifica al inicio las versiones mínimas de requirements.txt y usa semilla fija en 42. Cada acción del pipeline queda en una bitácora de diez pasos con su efecto en los datos, y las decisiones de selección, en una tabla única, y el destino de cada una de las 36 columnas, en un inventario.</a:t>
             </a:r>
           </a:p>
           <a:p/>
@@ -2544,13 +2544,13 @@
           <a:p/>
           <a:p>
             <a:r>
-              <a:t>"Ahora, los supuestos y las limitaciones. Asumimos que los 15 registros con tarifa cero, todos hombres, son un valor legítimo del dominio, posiblemente personal de la naviera, aunque no podemos confirmarlo. Asumimos también que nuestros criterios bastan para una selección preliminar, que debe revalidarse con el desempeño de un modelo real, en particular el descarte de Age_clean, y que el one-hot es adecuado con 891 filas.</a:t>
+              <a:t>"Ahora, los supuestos y las limitaciones. Asumimos que los 15 registros con tarifa cero, todos hombres, son un valor legítimo del dominio, posiblemente personal de la naviera, aunque no podemos confirmarlo. Asumimos también que nuestros criterios bastan para una selección preliminar, que debe revalidarse con el desempeño de un modelo real, en particular el descarte de Age_clean, que el one-hot es adecuado con 891 filas, y que las URL de origen de los datos seguirán disponibles, porque el notebook los lee desde internet.</a:t>
             </a:r>
           </a:p>
           <a:p/>
           <a:p>
             <a:r>
-              <a:t>Entre las limitaciones: Deck_combinado es 77 por ciento 'Desconocida', una categoría explícita y no imputada; persiste una redundancia parcial entre Title_agrupado y Sex_Pclass; la evidencia de relevancia es univariada y no descarta otras interacciones; y con 891 casos, los subgrupos pequeños son frágiles.</a:t>
+              <a:t>Entre las limitaciones: Deck_combinado es 77 por ciento 'Desconocida', una categoría explícita y no imputada; Title_agrupado y Sex_Pclass comparten casi toda la información de sexo, aunque sin redundancia exacta; la evidencia de relevancia es univariada y no descarta otras interacciones; y con 891 casos, los subgrupos pequeños son frágiles.</a:t>
             </a:r>
           </a:p>
           <a:p/>
@@ -2770,7 +2770,7 @@
           <a:p/>
           <a:p>
             <a:r>
-              <a:t>En esta última fase el objetivo no es entrenar un modelo, sino dejar los datos listos para modelar. Eso significa aplicar transformaciones justificadas, crear pocas variables derivadas con un valor analítico claro y seleccionar características con criterios explícitos, todo de forma reproducible.</a:t>
+              <a:t>En esta última fase el objetivo no es entrenar un modelo predictivo, sino dejar los datos listos para modelar. Eso significa aplicar transformaciones justificadas, crear pocas variables derivadas con un valor analítico claro y seleccionar características con criterios explícitos, todo de forma reproducible.</a:t>
             </a:r>
           </a:p>
           <a:p/>
@@ -2880,7 +2880,7 @@
           <a:p/>
           <a:p>
             <a:r>
-              <a:t>Todo eso quedó en titanic_prepared.csv, con 891 filas y 32 columnas. La Fase 4 parte exactamente de ahí: no vuelve al dato crudo, reutiliza esa limpieza validada y construye el dataset final de características."</a:t>
+              <a:t>Todo eso quedó en un dataset preparado de 891 filas y 32 columnas. En la Fase 4, el notebook lee las fuentes originales directamente desde GitHub, reproduce esa misma preparación sin cambios y, sobre ella, construye el dataset final de características."</a:t>
             </a:r>
           </a:p>
           <a:p/>
@@ -3100,7 +3100,7 @@
           <a:p/>
           <a:p>
             <a:r>
-              <a:t>"Gracias, Arturo. Antes del detalle, esta es la visión general del pipeline de la Fase 4. Parte de titanic_prepared.csv, con 891 filas y 32 columnas, y sigue cinco pasos.</a:t>
+              <a:t>"Gracias, Arturo. Antes del detalle, esta es la visión general del pipeline de la Fase 4. Parte del dataset preparado de las Fases 2-3, reproducido desde las fuentes originales, con 891 filas y 32 columnas, y sigue cinco pasos.</a:t>
             </a:r>
           </a:p>
           <a:p/>
@@ -8171,7 +8171,7 @@
                 </a:solidFill>
                 <a:latin typeface="Calibri"/>
               </a:rPr>
-              <a:t>Las 6 columnas heredadas (class, who, adult_male, deck, embark_town, alone) se reconstruyen al 100 % desde columnas propias.</a:t>
+              <a:t>Las 6 columnas heredadas (class, who, adult_male, deck, embark_town, alone) coinciden con columnas propias.</a:t>
             </a:r>
           </a:p>
         </p:txBody>
@@ -10592,7 +10592,7 @@
                 </a:solidFill>
                 <a:latin typeface="Calibri"/>
               </a:rPr>
-              <a:t>titanic_prepared.csv (891 × 32) → titanic_features.csv (891 × 29)</a:t>
+              <a:t>Dataset preparado (891 × 32) → titanic_features.csv (891 × 29)</a:t>
             </a:r>
           </a:p>
         </p:txBody>
@@ -11042,7 +11042,7 @@
                 </a:solidFill>
                 <a:latin typeface="Calibri"/>
               </a:rPr>
-              <a:t>columnas redundantes
+              <a:t>columnas
 descartadas</a:t>
             </a:r>
           </a:p>
@@ -11698,7 +11698,7 @@
                 </a:solidFill>
                 <a:latin typeface="Calibri"/>
               </a:rPr>
-              <a:t>Se eliminó la duplicación de señal (6 heredadas + 8 propias).</a:t>
+              <a:t>Se descartaron 14 columnas con criterio explícito (12 por redundancia).</a:t>
             </a:r>
           </a:p>
           <a:p>
@@ -12884,7 +12884,7 @@
                 </a:solidFill>
                 <a:latin typeface="Calibri"/>
               </a:rPr>
-              <a:t>Rutas relativas y semilla fija (RANDOM_STATE = 42)</a:t>
+              <a:t>Datos leídos desde GitHub y semilla fija (RANDOM_STATE = 42)</a:t>
             </a:r>
           </a:p>
           <a:p>
@@ -12905,7 +12905,7 @@
                 </a:solidFill>
                 <a:latin typeface="Calibri"/>
               </a:rPr>
-              <a:t>Dependencias en requirements.txt</a:t>
+              <a:t>Versiones de requirements.txt verificadas al inicio (II.1)</a:t>
             </a:r>
           </a:p>
           <a:p>
@@ -14522,6 +14522,27 @@
               <a:t>El one-hot es adecuado con 891 filas.</a:t>
             </a:r>
           </a:p>
+          <a:p>
+            <a:pPr algn="l" marL="219456" indent="-219456">
+              <a:spcAft>
+                <a:spcPts val="1000"/>
+              </a:spcAft>
+              <a:buClr>
+                <a:srgbClr val="4FC3F7"/>
+              </a:buClr>
+              <a:buFont typeface="Arial"/>
+              <a:buChar char="▸"/>
+            </a:pPr>
+            <a:r>
+              <a:rPr sz="1400" b="0" i="0">
+                <a:solidFill>
+                  <a:srgbClr val="B0C4DE"/>
+                </a:solidFill>
+                <a:latin typeface="Calibri"/>
+              </a:rPr>
+              <a:t>La ejecución requiere internet y que las URL de origen sigan disponibles.</a:t>
+            </a:r>
+          </a:p>
         </p:txBody>
       </p:sp>
       <p:sp>
@@ -14711,7 +14732,7 @@
                 </a:solidFill>
                 <a:latin typeface="Calibri"/>
               </a:rPr>
-              <a:t>Persiste redundancia parcial entre Title_agrupado y Sex_Pclass (R² ≈ 0,99).</a:t>
+              <a:t>Title_agrupado y Sex_Pclass comparten la información de sexo (R² ≈ 0,99 al predecir Sex desde el título), sin redundancia exacta.</a:t>
             </a:r>
           </a:p>
           <a:p>
@@ -16392,7 +16413,7 @@
                 </a:solidFill>
                 <a:latin typeface="Calibri"/>
               </a:rPr>
-              <a:t>entrenar modelos queda
+              <a:t>el modelo predictivo queda
 fuera de esta fase (RA4)</a:t>
             </a:r>
           </a:p>
@@ -16944,7 +16965,7 @@
                 </a:solidFill>
                 <a:latin typeface="Calibri"/>
               </a:rPr>
-              <a:t>Titanic (Kaggle) integrado con seaborn-data → titanic_prepared.csv, el punto de partida de la Fase 4</a:t>
+              <a:t>Titanic (Kaggle) + seaborn-data, leídos desde GitHub → dataset preparado, punto de partida de la Fase 4</a:t>
             </a:r>
           </a:p>
         </p:txBody>
@@ -17783,7 +17804,7 @@
                 </a:solidFill>
                 <a:latin typeface="Calibri"/>
               </a:rPr>
-              <a:t>Entrada: titanic_prepared.csv (891 × 32)</a:t>
+              <a:t>Entrada: fuentes originales (GitHub)</a:t>
             </a:r>
           </a:p>
           <a:p>
@@ -17825,7 +17846,7 @@
                 </a:solidFill>
                 <a:latin typeface="Calibri"/>
               </a:rPr>
-              <a:t>Sin volver al dato crudo</a:t>
+              <a:t>Reproduce F2-3 en memoria (891 × 32)</a:t>
             </a:r>
           </a:p>
         </p:txBody>
@@ -18269,7 +18290,7 @@
                 </a:solidFill>
                 <a:latin typeface="Calibri"/>
               </a:rPr>
-              <a:t>titanic_prepared.csv (preparado)</a:t>
+              <a:t>Dataset preparado (reproducido)</a:t>
             </a:r>
           </a:p>
         </p:txBody>
@@ -18352,7 +18373,7 @@
                 </a:solidFill>
                 <a:latin typeface="Calibri"/>
               </a:rPr>
-              <a:t>La Fase 4 no vuelve al dato crudo: reutiliza la limpieza, la imputación y la integración validadas en las Fases 2-3 y construye encima de ellas, dejando cada decisión documentada en el notebook.</a:t>
+              <a:t>La Fase 4 lee las fuentes originales desde GitHub, reproduce la limpieza, la imputación y la integración validadas en las Fases 2-3 y construye encima de ellas, dejando cada decisión documentada en el notebook.</a:t>
             </a:r>
           </a:p>
         </p:txBody>
@@ -19762,7 +19783,7 @@
                 </a:solidFill>
                 <a:latin typeface="Calibri"/>
               </a:rPr>
-              <a:t>De un dataset de 891 × 32 a un conjunto de características de 891 × 29, sin entrenar modelos</a:t>
+              <a:t>De un dataset de 891 × 32 a un conjunto de características de 891 × 29, sin entrenar un modelo predictivo</a:t>
             </a:r>
           </a:p>
         </p:txBody>
@@ -21149,7 +21170,7 @@
                 <a:latin typeface="Calibri"/>
               </a:rPr>
               <a:t>entrada:
-titanic_prepared.csv</a:t>
+dataset preparado</a:t>
             </a:r>
           </a:p>
         </p:txBody>
@@ -21517,7 +21538,7 @@
                 </a:solidFill>
                 <a:latin typeface="Calibri"/>
               </a:rPr>
-              <a:t>columnas redundantes
+              <a:t>columnas
 descartadas</a:t>
             </a:r>
           </a:p>

</xml_diff>